<commit_message>
Numbers slide: reorder to Nisha's talk track, add reviewer-hours gap note
Co-Authored-By: Claude Sonnet 5.5 <noreply@anthropic.com>
</commit_message>
<xml_diff>
--- a/deck/journey/Numbers.pptx
+++ b/deck/journey/Numbers.pptx
@@ -502,10 +502,12 @@
           <a:p>
             <a:r>
               <a:rPr lang="en-US" dirty="0"/>
-              <a:t>Start with the good news. Humana is fast. In its own 2025 reports, a standard decision takes one day on average, against a seven-day federal limit. Expedited decisions take between four and eleven hours, against seventy-two. And it does this at scale: 9.5 million standard requests in a year.
-But fast is not the same as right. When a denial is appealed, it is often reversed. Across all of Medicare Advantage, KFF found 80.7 percent of appealed denials were overturned in 2024. For Humana, its own reports show 64.7 percent. And the Inspector General found 95 percent of appealed skilled nursing denials were overturned. Be careful with these: only a small share of denials are appealed, about 2.7 percent at Humana, so this does not mean most denials are wrong. And an overturn can come from new information. But that is exactly the point. The first look was missing something.
-On the human side, physicians report that prior authorization delays care at least some of the time, 93 percent, and 26 percent say it led to a serious adverse event for a patient. These are physician reports, not patient counts.
-So an overturned denial is care that was delayed. Speed is already good. What we have to get right is the first decision.</a:t>
+              <a:t>I read Humana's own public reports, and Humana is fast. A standard decision takes one day on average. The federal limit is seven. An expedited decision takes four to eleven hours, and the federal limit is seventy-two. And that is across nine and a half million requests. That is real operational strength.
+But fast is not the same as right. Sixty-five percent of appealed Humana denials were overturned. That comes from Humana's own federal report for 2025. I do not claim sixty-five percent of denials are wrong. Only about three percent of denials are appealed. But the ones that are appealed get reversed most of the time, and an overturn often comes from new information. That is my point. The first look was missing something.
+Zoom out and the problem is bigger. Across all of Medicare Advantage, eighty-one percent of appealed denials were overturned in 2024. And the Inspector General found ninety-five percent of appealed skilled nursing denials were overturned.
+There is another side of the coin. We may not solve this one directly, but it adds color to the problem. Physicians feel it, and they are the people closest to the patient. Ninety-three percent say prior authorization can delay care. Twenty-six percent report a serious adverse event for a patient.
+One more thing. I could not find a report from Humana or from the federal government on how many hours reviewers spend on prior authorization. A physician reports thirteen hours a week. I will not say a utilization nurse spends the same. But with nine and a half million requests, and fourteen pages to read and check against policy on each one, I would expect a big part of their shift goes to this. A pilot is how we would measure it.
+So we want to be right, and stay inside the federal limits. But the biggest goal is to be correct. An overturned denial is care that was delayed. Our goal is not to be faster. Our goal is to be right the first time. And speed becomes a line we do not cross.</a:t>
             </a:r>
             <a:endParaRPr lang="en-US" dirty="0"/>
           </a:p>
@@ -1042,7 +1044,7 @@
         </p:nvSpPr>
         <p:spPr>
           <a:xfrm>
-            <a:off x="457200" y="1371600"/>
+            <a:off x="457200" y="1325880"/>
             <a:ext cx="11274552" cy="237744"/>
           </a:xfrm>
           <a:prstGeom prst="rect">
@@ -1081,12 +1083,12 @@
         </p:nvSpPr>
         <p:spPr>
           <a:xfrm>
-            <a:off x="457200" y="1645920"/>
-            <a:ext cx="3657600" cy="1280160"/>
+            <a:off x="457200" y="1572768"/>
+            <a:ext cx="3657600" cy="1188720"/>
           </a:xfrm>
           <a:prstGeom prst="roundRect">
             <a:avLst>
-              <a:gd name="adj" fmla="val 5714"/>
+              <a:gd name="adj" fmla="val 6154"/>
             </a:avLst>
           </a:prstGeom>
           <a:solidFill>
@@ -1165,12 +1167,12 @@
         </p:nvSpPr>
         <p:spPr>
           <a:xfrm>
-            <a:off x="4265676" y="1645920"/>
-            <a:ext cx="3657600" cy="1280160"/>
+            <a:off x="4265676" y="1572768"/>
+            <a:ext cx="3657600" cy="1188720"/>
           </a:xfrm>
           <a:prstGeom prst="roundRect">
             <a:avLst>
-              <a:gd name="adj" fmla="val 5714"/>
+              <a:gd name="adj" fmla="val 6154"/>
             </a:avLst>
           </a:prstGeom>
           <a:solidFill>
@@ -1249,12 +1251,12 @@
         </p:nvSpPr>
         <p:spPr>
           <a:xfrm>
-            <a:off x="8074152" y="1645920"/>
-            <a:ext cx="3657600" cy="1280160"/>
+            <a:off x="8074152" y="1572768"/>
+            <a:ext cx="3657600" cy="1188720"/>
           </a:xfrm>
           <a:prstGeom prst="roundRect">
             <a:avLst>
-              <a:gd name="adj" fmla="val 5714"/>
+              <a:gd name="adj" fmla="val 6154"/>
             </a:avLst>
           </a:prstGeom>
           <a:solidFill>
@@ -1333,7 +1335,7 @@
         </p:nvSpPr>
         <p:spPr>
           <a:xfrm>
-            <a:off x="457200" y="3090672"/>
+            <a:off x="457200" y="2871216"/>
             <a:ext cx="11274552" cy="237744"/>
           </a:xfrm>
           <a:prstGeom prst="rect">
@@ -1372,12 +1374,12 @@
         </p:nvSpPr>
         <p:spPr>
           <a:xfrm>
-            <a:off x="457200" y="3364992"/>
-            <a:ext cx="3657600" cy="1371600"/>
+            <a:off x="457200" y="3127248"/>
+            <a:ext cx="3657600" cy="1417320"/>
           </a:xfrm>
           <a:prstGeom prst="roundRect">
             <a:avLst>
-              <a:gd name="adj" fmla="val 5333"/>
+              <a:gd name="adj" fmla="val 5161"/>
             </a:avLst>
           </a:prstGeom>
           <a:solidFill>
@@ -1397,6 +1399,23 @@
               <a:buNone/>
             </a:pPr>
             <a:r>
+              <a:rPr lang="en-US" sz="950" b="1" spc="200" kern="0" dirty="0">
+                <a:solidFill>
+                  <a:srgbClr val="B8452F"/>
+                </a:solidFill>
+                <a:latin typeface="Calibri" pitchFamily="34" charset="0"/>
+                <a:ea typeface="Calibri" pitchFamily="34" charset="-122"/>
+                <a:cs typeface="Calibri" pitchFamily="34" charset="-120"/>
+              </a:rPr>
+              <a:t>HUMANA</a:t>
+            </a:r>
+            <a:endParaRPr lang="en-US" sz="950" dirty="0"/>
+          </a:p>
+          <a:p>
+            <a:pPr algn="l" indent="0" marL="0">
+              <a:buNone/>
+            </a:pPr>
+            <a:r>
               <a:rPr lang="en-US" sz="3600" dirty="0">
                 <a:solidFill>
                   <a:srgbClr val="B8452F"/>
@@ -1405,9 +1424,9 @@
                 <a:ea typeface="Cambria" pitchFamily="34" charset="-122"/>
                 <a:cs typeface="Cambria" pitchFamily="34" charset="-120"/>
               </a:rPr>
-              <a:t>80.7%</a:t>
-            </a:r>
-            <a:endParaRPr lang="en-US" sz="3600" dirty="0"/>
+              <a:t>64.7%</a:t>
+            </a:r>
+            <a:endParaRPr lang="en-US" sz="950" dirty="0"/>
           </a:p>
           <a:p>
             <a:pPr algn="l" indent="0" marL="0">
@@ -1425,9 +1444,9 @@
                 <a:ea typeface="Calibri" pitchFamily="34" charset="-122"/>
                 <a:cs typeface="Calibri" pitchFamily="34" charset="-120"/>
               </a:rPr>
-              <a:t>of appealed denials were overturned across Medicare Advantage</a:t>
-            </a:r>
-            <a:endParaRPr lang="en-US" sz="3600" dirty="0"/>
+              <a:t>of appealed Humana denials were overturned</a:t>
+            </a:r>
+            <a:endParaRPr lang="en-US" sz="950" dirty="0"/>
           </a:p>
           <a:p>
             <a:pPr algn="l" indent="0" marL="0">
@@ -1442,9 +1461,9 @@
                 <a:ea typeface="Calibri" pitchFamily="34" charset="-122"/>
                 <a:cs typeface="Calibri" pitchFamily="34" charset="-120"/>
               </a:rPr>
-              <a:t>KFF, 2024. 53 million requests, 4.1 million denied.</a:t>
-            </a:r>
-            <a:endParaRPr lang="en-US" sz="3600" dirty="0"/>
+              <a:t>Humana's own federal reports, 2025. Only 2.7% of denials are appealed, so we do not claim 65% of denials are wrong.</a:t>
+            </a:r>
+            <a:endParaRPr lang="en-US" sz="950" dirty="0"/>
           </a:p>
         </p:txBody>
       </p:sp>
@@ -1456,12 +1475,12 @@
         </p:nvSpPr>
         <p:spPr>
           <a:xfrm>
-            <a:off x="4265676" y="3364992"/>
-            <a:ext cx="3657600" cy="1371600"/>
+            <a:off x="4265676" y="3127248"/>
+            <a:ext cx="3657600" cy="1417320"/>
           </a:xfrm>
           <a:prstGeom prst="roundRect">
             <a:avLst>
-              <a:gd name="adj" fmla="val 5333"/>
+              <a:gd name="adj" fmla="val 5161"/>
             </a:avLst>
           </a:prstGeom>
           <a:solidFill>
@@ -1481,6 +1500,23 @@
               <a:buNone/>
             </a:pPr>
             <a:r>
+              <a:rPr lang="en-US" sz="950" b="1" spc="200" kern="0" dirty="0">
+                <a:solidFill>
+                  <a:srgbClr val="B8452F"/>
+                </a:solidFill>
+                <a:latin typeface="Calibri" pitchFamily="34" charset="0"/>
+                <a:ea typeface="Calibri" pitchFamily="34" charset="-122"/>
+                <a:cs typeface="Calibri" pitchFamily="34" charset="-120"/>
+              </a:rPr>
+              <a:t>THE WIDER PICTURE</a:t>
+            </a:r>
+            <a:endParaRPr lang="en-US" sz="950" dirty="0"/>
+          </a:p>
+          <a:p>
+            <a:pPr algn="l" indent="0" marL="0">
+              <a:buNone/>
+            </a:pPr>
+            <a:r>
               <a:rPr lang="en-US" sz="3600" dirty="0">
                 <a:solidFill>
                   <a:srgbClr val="B8452F"/>
@@ -1489,9 +1525,9 @@
                 <a:ea typeface="Cambria" pitchFamily="34" charset="-122"/>
                 <a:cs typeface="Cambria" pitchFamily="34" charset="-120"/>
               </a:rPr>
-              <a:t>64.7%</a:t>
-            </a:r>
-            <a:endParaRPr lang="en-US" sz="3600" dirty="0"/>
+              <a:t>80.7%</a:t>
+            </a:r>
+            <a:endParaRPr lang="en-US" sz="950" dirty="0"/>
           </a:p>
           <a:p>
             <a:pPr algn="l" indent="0" marL="0">
@@ -1509,9 +1545,9 @@
                 <a:ea typeface="Calibri" pitchFamily="34" charset="-122"/>
                 <a:cs typeface="Calibri" pitchFamily="34" charset="-120"/>
               </a:rPr>
-              <a:t>of appealed Humana denials were overturned</a:t>
-            </a:r>
-            <a:endParaRPr lang="en-US" sz="3600" dirty="0"/>
+              <a:t>of appealed denials were overturned across Medicare Advantage</a:t>
+            </a:r>
+            <a:endParaRPr lang="en-US" sz="950" dirty="0"/>
           </a:p>
           <a:p>
             <a:pPr algn="l" indent="0" marL="0">
@@ -1526,9 +1562,9 @@
                 <a:ea typeface="Calibri" pitchFamily="34" charset="-122"/>
                 <a:cs typeface="Calibri" pitchFamily="34" charset="-120"/>
               </a:rPr>
-              <a:t>Humana's own federal reports, 2025. Only 2.7% of denials are appealed.</a:t>
-            </a:r>
-            <a:endParaRPr lang="en-US" sz="3600" dirty="0"/>
+              <a:t>KFF, 2024. 53 million requests, 4.1 million denied.</a:t>
+            </a:r>
+            <a:endParaRPr lang="en-US" sz="950" dirty="0"/>
           </a:p>
         </p:txBody>
       </p:sp>
@@ -1540,12 +1576,12 @@
         </p:nvSpPr>
         <p:spPr>
           <a:xfrm>
-            <a:off x="8074152" y="3364992"/>
-            <a:ext cx="3657600" cy="1371600"/>
+            <a:off x="8074152" y="3127248"/>
+            <a:ext cx="3657600" cy="1417320"/>
           </a:xfrm>
           <a:prstGeom prst="roundRect">
             <a:avLst>
-              <a:gd name="adj" fmla="val 5333"/>
+              <a:gd name="adj" fmla="val 5161"/>
             </a:avLst>
           </a:prstGeom>
           <a:solidFill>
@@ -1565,6 +1601,23 @@
               <a:buNone/>
             </a:pPr>
             <a:r>
+              <a:rPr lang="en-US" sz="950" b="1" spc="200" kern="0" dirty="0">
+                <a:solidFill>
+                  <a:srgbClr val="B8452F"/>
+                </a:solidFill>
+                <a:latin typeface="Calibri" pitchFamily="34" charset="0"/>
+                <a:ea typeface="Calibri" pitchFamily="34" charset="-122"/>
+                <a:cs typeface="Calibri" pitchFamily="34" charset="-120"/>
+              </a:rPr>
+              <a:t>THE EXTREME</a:t>
+            </a:r>
+            <a:endParaRPr lang="en-US" sz="950" dirty="0"/>
+          </a:p>
+          <a:p>
+            <a:pPr algn="l" indent="0" marL="0">
+              <a:buNone/>
+            </a:pPr>
+            <a:r>
               <a:rPr lang="en-US" sz="3600" dirty="0">
                 <a:solidFill>
                   <a:srgbClr val="B8452F"/>
@@ -1575,7 +1628,7 @@
               </a:rPr>
               <a:t>95%</a:t>
             </a:r>
-            <a:endParaRPr lang="en-US" sz="3600" dirty="0"/>
+            <a:endParaRPr lang="en-US" sz="950" dirty="0"/>
           </a:p>
           <a:p>
             <a:pPr algn="l" indent="0" marL="0">
@@ -1595,7 +1648,7 @@
               </a:rPr>
               <a:t>of appealed skilled nursing denials were overturned</a:t>
             </a:r>
-            <a:endParaRPr lang="en-US" sz="3600" dirty="0"/>
+            <a:endParaRPr lang="en-US" sz="950" dirty="0"/>
           </a:p>
           <a:p>
             <a:pPr algn="l" indent="0" marL="0">
@@ -1612,7 +1665,7 @@
               </a:rPr>
               <a:t>HHS OIG, 19 plans, data from June 2024.</a:t>
             </a:r>
-            <a:endParaRPr lang="en-US" sz="3600" dirty="0"/>
+            <a:endParaRPr lang="en-US" sz="950" dirty="0"/>
           </a:p>
         </p:txBody>
       </p:sp>
@@ -1624,7 +1677,7 @@
         </p:nvSpPr>
         <p:spPr>
           <a:xfrm>
-            <a:off x="457200" y="4901184"/>
+            <a:off x="457200" y="4663440"/>
             <a:ext cx="11274552" cy="237744"/>
           </a:xfrm>
           <a:prstGeom prst="rect">
@@ -1649,7 +1702,7 @@
                 <a:ea typeface="Calibri" pitchFamily="34" charset="-122"/>
                 <a:cs typeface="Calibri" pitchFamily="34" charset="-120"/>
               </a:rPr>
-              <a:t>WHAT PHYSICIANS SEE</a:t>
+              <a:t>THE HUMAN SIDE: WHAT PHYSICIANS REPORT</a:t>
             </a:r>
             <a:endParaRPr lang="en-US" sz="1100" dirty="0"/>
           </a:p>
@@ -1663,12 +1716,12 @@
         </p:nvSpPr>
         <p:spPr>
           <a:xfrm>
-            <a:off x="457200" y="5175504"/>
-            <a:ext cx="3657600" cy="1188720"/>
+            <a:off x="457200" y="4919472"/>
+            <a:ext cx="3657600" cy="1234440"/>
           </a:xfrm>
           <a:prstGeom prst="roundRect">
             <a:avLst>
-              <a:gd name="adj" fmla="val 6154"/>
+              <a:gd name="adj" fmla="val 5926"/>
             </a:avLst>
           </a:prstGeom>
           <a:solidFill>
@@ -1747,12 +1800,12 @@
         </p:nvSpPr>
         <p:spPr>
           <a:xfrm>
-            <a:off x="4265676" y="5175504"/>
-            <a:ext cx="3657600" cy="1188720"/>
+            <a:off x="4265676" y="4919472"/>
+            <a:ext cx="3657600" cy="1234440"/>
           </a:xfrm>
           <a:prstGeom prst="roundRect">
             <a:avLst>
-              <a:gd name="adj" fmla="val 6154"/>
+              <a:gd name="adj" fmla="val 5926"/>
             </a:avLst>
           </a:prstGeom>
           <a:solidFill>
@@ -1831,12 +1884,12 @@
         </p:nvSpPr>
         <p:spPr>
           <a:xfrm>
-            <a:off x="8074152" y="5175504"/>
-            <a:ext cx="3657600" cy="1188720"/>
+            <a:off x="8074152" y="4919472"/>
+            <a:ext cx="3657600" cy="1234440"/>
           </a:xfrm>
           <a:prstGeom prst="roundRect">
             <a:avLst>
-              <a:gd name="adj" fmla="val 6154"/>
+              <a:gd name="adj" fmla="val 5926"/>
             </a:avLst>
           </a:prstGeom>
           <a:solidFill>
@@ -1884,9 +1937,48 @@
                 <a:ea typeface="Calibri" pitchFamily="34" charset="-122"/>
                 <a:cs typeface="Calibri" pitchFamily="34" charset="-120"/>
               </a:rPr>
-              <a:t>We have to be right the first time.</a:t>
+              <a:t>Our goal is not faster. It is right the first time.</a:t>
             </a:r>
             <a:endParaRPr lang="en-US" sz="1500" dirty="0"/>
+          </a:p>
+        </p:txBody>
+      </p:sp>
+      <p:sp>
+        <p:nvSpPr>
+          <p:cNvPr id="18" name="Gap"/>
+          <p:cNvSpPr txBox="1"/>
+          <p:nvPr/>
+        </p:nvSpPr>
+        <p:spPr>
+          <a:xfrm>
+            <a:off x="457200" y="6217920"/>
+            <a:ext cx="11274552" cy="256032"/>
+          </a:xfrm>
+          <a:prstGeom prst="rect">
+            <a:avLst/>
+          </a:prstGeom>
+          <a:noFill/>
+          <a:ln/>
+        </p:spPr>
+        <p:txBody>
+          <a:bodyPr wrap="square" lIns="0" tIns="0" rIns="0" bIns="0" rtlCol="0" anchor="ctr"/>
+          <a:lstStyle/>
+          <a:p>
+            <a:pPr algn="l" indent="0" marL="0">
+              <a:buNone/>
+            </a:pPr>
+            <a:r>
+              <a:rPr lang="en-US" sz="1100" i="1" dirty="0">
+                <a:solidFill>
+                  <a:srgbClr val="5C6B66"/>
+                </a:solidFill>
+                <a:latin typeface="Calibri" pitchFamily="34" charset="0"/>
+                <a:ea typeface="Calibri" pitchFamily="34" charset="-122"/>
+                <a:cs typeface="Calibri" pitchFamily="34" charset="-120"/>
+              </a:rPr>
+              <a:t>Not published by Humana or CMS: how many hours plan reviewers spend on prior authorization. That is a number we would measure in a pilot.</a:t>
+            </a:r>
+            <a:endParaRPr lang="en-US" sz="1100" dirty="0"/>
           </a:p>
         </p:txBody>
       </p:sp>

</xml_diff>

<commit_message>
Volume math on slides 3, 5, 6 (2.3M more requests, a nurse reads each) and the 85% idea on slide 6
Co-Authored-By: Claude Sonnet 5.5 <noreply@anthropic.com>
</commit_message>
<xml_diff>
--- a/deck/journey/Numbers.pptx
+++ b/deck/journey/Numbers.pptx
@@ -502,7 +502,7 @@
           <a:p>
             <a:r>
               <a:rPr lang="en-US" dirty="0"/>
-              <a:t>I read Humana's own public reports, and Humana is fast. A standard decision takes one day on average. The federal limit is seven. An expedited decision takes four to eleven hours, and the federal limit is seventy-two. And that is across nine and a half million requests. That is real operational strength.
+              <a:t>I read Humana's own public reports, and Humana is fast. A standard decision takes one day on average. The federal limit is seven. An expedited decision takes four to eleven hours, and the federal limit is seventy-two. And that is across nine and a half million requests. That is real operational strength. And the pile is growing. Humana added about a million members in a month, and a Humana member makes about 2.2 requests a year, so about 2.3 million more requests are coming, each one read by a nurse.
 But fast is not the same as right. Sixty-five percent of appealed Humana denials were overturned. That comes from Humana's own federal report for 2025. I do not claim sixty-five percent of denials are wrong. Only about three percent of denials are appealed. But the ones that are appealed get reversed most of the time, and an overturn often comes from new information. That is my point. The first look was missing something.
 Zoom out and the problem is bigger. Across all of Medicare Advantage, eighty-one percent of appealed denials were overturned in 2024. And the Inspector General found ninety-five percent of appealed skilled nursing denials were overturned.
 There is another side of the coin. We may not solve this one directly, but it adds color to the problem. Physicians feel it, and they are the people closest to the patient. Ninety-three percent say prior authorization can delay care. Twenty-six percent report a serious adverse event for a patient.
@@ -1321,7 +1321,7 @@
                 <a:ea typeface="Calibri" pitchFamily="34" charset="-122"/>
                 <a:cs typeface="Calibri" pitchFamily="34" charset="-120"/>
               </a:rPr>
-              <a:t>Humana, 32 Medicare Advantage contracts, 2025.</a:t>
+              <a:t>Humana, 2025. And about 2.3 million more are coming: 1.03M new members × 2.2 requests each (KFF).</a:t>
             </a:r>
             <a:endParaRPr lang="en-US" sz="3600" dirty="0"/>
           </a:p>

</xml_diff>

<commit_message>
Clarify timing: members joined in January, extra requests are per year
Co-Authored-By: Claude Sonnet 5.5 <noreply@anthropic.com>
</commit_message>
<xml_diff>
--- a/deck/journey/Numbers.pptx
+++ b/deck/journey/Numbers.pptx
@@ -502,7 +502,7 @@
           <a:p>
             <a:r>
               <a:rPr lang="en-US" dirty="0"/>
-              <a:t>I read Humana's own public reports, and Humana is fast. A standard decision takes one day on average. The federal limit is seven. An expedited decision takes four to eleven hours, and the federal limit is seventy-two. And that is across nine and a half million requests. That is real operational strength. And the pile is growing. Humana added about a million members in a month, and a Humana member makes about 2.2 requests a year, so about 2.3 million more requests are coming, each one read by a nurse.
+              <a:t>I read Humana's own public reports, and Humana is fast. A standard decision takes one day on average. The federal limit is seven. An expedited decision takes four to eleven hours, and the federal limit is seventy-two. And that is across nine and a half million requests. That is real operational strength. And the pile is growing. About a million members joined Humana in January, and a Humana member makes about 2.2 requests a year, so about 2.3 million more requests a year are coming, each one read by a nurse.
 But fast is not the same as right. Sixty-five percent of appealed Humana denials were overturned. That comes from Humana's own federal report for 2025. I do not claim sixty-five percent of denials are wrong. Only about three percent of denials are appealed. But the ones that are appealed get reversed most of the time, and an overturn often comes from new information. That is my point. The first look was missing something.
 Zoom out and the problem is bigger. Across all of Medicare Advantage, eighty-one percent of appealed denials were overturned in 2024. And the Inspector General found ninety-five percent of appealed skilled nursing denials were overturned.
 There is another side of the coin. We may not solve this one directly, but it adds color to the problem. Physicians feel it, and they are the people closest to the patient. Ninety-three percent say prior authorization can delay care. Twenty-six percent report a serious adverse event for a patient.
@@ -1321,7 +1321,7 @@
                 <a:ea typeface="Calibri" pitchFamily="34" charset="-122"/>
                 <a:cs typeface="Calibri" pitchFamily="34" charset="-120"/>
               </a:rPr>
-              <a:t>Humana, 2025. And about 2.3 million more are coming: 1.03M new members × 2.2 requests each (KFF).</a:t>
+              <a:t>Humana, 2025. And about 2.3 million more a year are coming: 1.03M new members × 2.2 requests each (KFF).</a:t>
             </a:r>
             <a:endParaRPr lang="en-US" sz="3600" dirty="0"/>
           </a:p>

</xml_diff>

<commit_message>
Correct the KFF claim: 2.2 is an average and not the highest
Co-Authored-By: Claude Sonnet 5.5 <noreply@anthropic.com>
</commit_message>
<xml_diff>
--- a/deck/journey/Numbers.pptx
+++ b/deck/journey/Numbers.pptx
@@ -502,7 +502,7 @@
           <a:p>
             <a:r>
               <a:rPr lang="en-US" dirty="0"/>
-              <a:t>I read Humana's own public reports, and Humana is fast. A standard decision takes one day on average. The federal limit is seven. An expedited decision takes four to eleven hours, and the federal limit is seventy-two. And that is across nine and a half million requests. That is real operational strength. And the pile is growing. About a million members joined Humana in January, and a Humana member makes about 2.2 requests a year, so about 2.3 million more requests a year are coming, each one read by a nurse.
+              <a:t>I read Humana's own public reports, and Humana is fast. A standard decision takes one day on average. The federal limit is seven. An expedited decision takes four to eleven hours, and the federal limit is seventy-two. And that is across nine and a half million requests. That is real operational strength. And the pile is growing. About a million members joined Humana in January, and a Humana member averages about 2.2 requests a year, so about 2.3 million more requests a year are coming, each one read by a nurse.
 But fast is not the same as right. Sixty-five percent of appealed Humana denials were overturned. That comes from Humana's own federal report for 2025. I do not claim sixty-five percent of denials are wrong. Only about three percent of denials are appealed. But the ones that are appealed get reversed most of the time, and an overturn often comes from new information. That is my point. The first look was missing something.
 Zoom out and the problem is bigger. Across all of Medicare Advantage, eighty-one percent of appealed denials were overturned in 2024. And the Inspector General found ninety-five percent of appealed skilled nursing denials were overturned.
 There is another side of the coin. We may not solve this one directly, but it adds color to the problem. Physicians feel it, and they are the people closest to the patient. Ninety-three percent say prior authorization can delay care. Twenty-six percent report a serious adverse event for a patient.
@@ -1321,7 +1321,7 @@
                 <a:ea typeface="Calibri" pitchFamily="34" charset="-122"/>
                 <a:cs typeface="Calibri" pitchFamily="34" charset="-120"/>
               </a:rPr>
-              <a:t>Humana, 2025. And about 2.3 million more a year are coming: 1.03M new members × 2.2 requests each (KFF).</a:t>
+              <a:t>Humana, 2025. And about 2.3 million more a year are coming: 1.03M new members × 2.2 requests each, on average (KFF).</a:t>
             </a:r>
             <a:endParaRPr lang="en-US" sz="3600" dirty="0"/>
           </a:p>

</xml_diff>